<commit_message>
added helloRouting and rateItFinal Applications
</commit_message>
<xml_diff>
--- a/Unit 2/Reusable_Components_Updated.pptx
+++ b/Unit 2/Reusable_Components_Updated.pptx
@@ -236,7 +236,7 @@
           <a:p>
             <a:fld id="{5BF58AE4-3B94-4A76-99DF-52B8754DC799}" type="datetimeFigureOut">
               <a:rPr lang="en-US" smtClean="0"/>
-              <a:t>9/12/2026</a:t>
+              <a:t>9/21/2026</a:t>
             </a:fld>
             <a:endParaRPr lang="en-US"/>
           </a:p>
@@ -3386,7 +3386,7 @@
           <a:p>
             <a:fld id="{5BCAD085-E8A6-8845-BD4E-CB4CCA059FC4}" type="datetimeFigureOut">
               <a:rPr lang="en-US" smtClean="0"/>
-              <a:t>9/12/2026</a:t>
+              <a:t>9/21/2026</a:t>
             </a:fld>
             <a:endParaRPr lang="en-US"/>
           </a:p>
@@ -3554,7 +3554,7 @@
           <a:p>
             <a:fld id="{5BCAD085-E8A6-8845-BD4E-CB4CCA059FC4}" type="datetimeFigureOut">
               <a:rPr lang="en-US" smtClean="0"/>
-              <a:t>9/12/2026</a:t>
+              <a:t>9/21/2026</a:t>
             </a:fld>
             <a:endParaRPr lang="en-US"/>
           </a:p>
@@ -3732,7 +3732,7 @@
           <a:p>
             <a:fld id="{5BCAD085-E8A6-8845-BD4E-CB4CCA059FC4}" type="datetimeFigureOut">
               <a:rPr lang="en-US" smtClean="0"/>
-              <a:t>9/12/2026</a:t>
+              <a:t>9/21/2026</a:t>
             </a:fld>
             <a:endParaRPr lang="en-US"/>
           </a:p>
@@ -3900,7 +3900,7 @@
           <a:p>
             <a:fld id="{5BCAD085-E8A6-8845-BD4E-CB4CCA059FC4}" type="datetimeFigureOut">
               <a:rPr lang="en-US" smtClean="0"/>
-              <a:t>9/12/2026</a:t>
+              <a:t>9/21/2026</a:t>
             </a:fld>
             <a:endParaRPr lang="en-US"/>
           </a:p>
@@ -4145,7 +4145,7 @@
           <a:p>
             <a:fld id="{5BCAD085-E8A6-8845-BD4E-CB4CCA059FC4}" type="datetimeFigureOut">
               <a:rPr lang="en-US" smtClean="0"/>
-              <a:t>9/12/2026</a:t>
+              <a:t>9/21/2026</a:t>
             </a:fld>
             <a:endParaRPr lang="en-US"/>
           </a:p>
@@ -4430,7 +4430,7 @@
           <a:p>
             <a:fld id="{5BCAD085-E8A6-8845-BD4E-CB4CCA059FC4}" type="datetimeFigureOut">
               <a:rPr lang="en-US" smtClean="0"/>
-              <a:t>9/12/2026</a:t>
+              <a:t>9/21/2026</a:t>
             </a:fld>
             <a:endParaRPr lang="en-US"/>
           </a:p>
@@ -4849,7 +4849,7 @@
           <a:p>
             <a:fld id="{5BCAD085-E8A6-8845-BD4E-CB4CCA059FC4}" type="datetimeFigureOut">
               <a:rPr lang="en-US" smtClean="0"/>
-              <a:t>9/12/2026</a:t>
+              <a:t>9/21/2026</a:t>
             </a:fld>
             <a:endParaRPr lang="en-US"/>
           </a:p>
@@ -4966,7 +4966,7 @@
           <a:p>
             <a:fld id="{5BCAD085-E8A6-8845-BD4E-CB4CCA059FC4}" type="datetimeFigureOut">
               <a:rPr lang="en-US" smtClean="0"/>
-              <a:t>9/12/2026</a:t>
+              <a:t>9/21/2026</a:t>
             </a:fld>
             <a:endParaRPr lang="en-US"/>
           </a:p>
@@ -5061,7 +5061,7 @@
           <a:p>
             <a:fld id="{5BCAD085-E8A6-8845-BD4E-CB4CCA059FC4}" type="datetimeFigureOut">
               <a:rPr lang="en-US" smtClean="0"/>
-              <a:t>9/12/2026</a:t>
+              <a:t>9/21/2026</a:t>
             </a:fld>
             <a:endParaRPr lang="en-US"/>
           </a:p>
@@ -5372,7 +5372,7 @@
           <a:p>
             <a:fld id="{5BCAD085-E8A6-8845-BD4E-CB4CCA059FC4}" type="datetimeFigureOut">
               <a:rPr lang="en-US" smtClean="0"/>
-              <a:t>9/12/2026</a:t>
+              <a:t>9/21/2026</a:t>
             </a:fld>
             <a:endParaRPr lang="en-US"/>
           </a:p>
@@ -5624,7 +5624,7 @@
           <a:p>
             <a:fld id="{5BCAD085-E8A6-8845-BD4E-CB4CCA059FC4}" type="datetimeFigureOut">
               <a:rPr lang="en-US" smtClean="0"/>
-              <a:t>9/12/2026</a:t>
+              <a:t>9/21/2026</a:t>
             </a:fld>
             <a:endParaRPr lang="en-US"/>
           </a:p>
@@ -5835,7 +5835,7 @@
           <a:p>
             <a:fld id="{5BCAD085-E8A6-8845-BD4E-CB4CCA059FC4}" type="datetimeFigureOut">
               <a:rPr lang="en-US" smtClean="0"/>
-              <a:t>9/12/2026</a:t>
+              <a:t>9/21/2026</a:t>
             </a:fld>
             <a:endParaRPr lang="en-US"/>
           </a:p>
@@ -16735,7 +16735,7 @@
                   <a:srgbClr val="111827"/>
                 </a:solidFill>
               </a:rPr>
-              <a:t> — Key Concepts Explained  (2 of 3)</a:t>
+              <a:t> — Key Concepts Explained  (3 of 3 Cont’d)</a:t>
             </a:r>
           </a:p>
         </p:txBody>

</xml_diff>